<commit_message>
lec 1 typo fix
</commit_message>
<xml_diff>
--- a/Lectures/Lecture1.pptx
+++ b/Lectures/Lecture1.pptx
@@ -365,7 +365,7 @@
           <a:p>
             <a:fld id="{CBA08D16-15DC-4E25-BDC3-F25146157B16}" type="datetimeFigureOut">
               <a:rPr lang="ru-RU" smtClean="0"/>
-              <a:t>02.09.2026</a:t>
+              <a:t>03.09.2026</a:t>
             </a:fld>
             <a:endParaRPr lang="ru-RU"/>
           </a:p>
@@ -941,7 +941,7 @@
           <a:p>
             <a:fld id="{FCEC8293-DB51-454A-BE81-EC8FCB31EBA2}" type="datetime1">
               <a:rPr lang="ru-RU" smtClean="0"/>
-              <a:t>02.09.2026</a:t>
+              <a:t>03.09.2026</a:t>
             </a:fld>
             <a:endParaRPr lang="ru-RU"/>
           </a:p>
@@ -1112,7 +1112,7 @@
           <a:p>
             <a:fld id="{241C87B1-1C35-4DBD-BC18-2BC72E776603}" type="datetime1">
               <a:rPr lang="ru-RU" smtClean="0"/>
-              <a:t>02.09.2026</a:t>
+              <a:t>03.09.2026</a:t>
             </a:fld>
             <a:endParaRPr lang="ru-RU"/>
           </a:p>
@@ -1293,7 +1293,7 @@
           <a:p>
             <a:fld id="{3134C275-26C0-42CD-9111-9ADE65922AF9}" type="datetime1">
               <a:rPr lang="ru-RU" smtClean="0"/>
-              <a:t>02.09.2026</a:t>
+              <a:t>03.09.2026</a:t>
             </a:fld>
             <a:endParaRPr lang="ru-RU"/>
           </a:p>
@@ -1464,7 +1464,7 @@
           <a:p>
             <a:fld id="{C1A9A50B-C350-45F5-8AAB-ADB9E670AF2E}" type="datetime1">
               <a:rPr lang="ru-RU" smtClean="0"/>
-              <a:t>02.09.2026</a:t>
+              <a:t>03.09.2026</a:t>
             </a:fld>
             <a:endParaRPr lang="ru-RU"/>
           </a:p>
@@ -1712,7 +1712,7 @@
           <a:p>
             <a:fld id="{089688C9-348F-42F9-B6C0-5990DDE0C5B2}" type="datetime1">
               <a:rPr lang="ru-RU" smtClean="0"/>
-              <a:t>02.09.2026</a:t>
+              <a:t>03.09.2026</a:t>
             </a:fld>
             <a:endParaRPr lang="ru-RU"/>
           </a:p>
@@ -1944,7 +1944,7 @@
           <a:p>
             <a:fld id="{684AFD8F-6DD9-4AD3-A505-FDC3F5C5F3F6}" type="datetime1">
               <a:rPr lang="ru-RU" smtClean="0"/>
-              <a:t>02.09.2026</a:t>
+              <a:t>03.09.2026</a:t>
             </a:fld>
             <a:endParaRPr lang="ru-RU"/>
           </a:p>
@@ -2311,7 +2311,7 @@
           <a:p>
             <a:fld id="{63551EFE-4D02-45EB-A747-8B6F047B5AA0}" type="datetime1">
               <a:rPr lang="ru-RU" smtClean="0"/>
-              <a:t>02.09.2026</a:t>
+              <a:t>03.09.2026</a:t>
             </a:fld>
             <a:endParaRPr lang="ru-RU"/>
           </a:p>
@@ -2431,7 +2431,7 @@
           <a:p>
             <a:fld id="{813A9F34-E5CD-4B8F-AA9E-889C84372B20}" type="datetime1">
               <a:rPr lang="ru-RU" smtClean="0"/>
-              <a:t>02.09.2026</a:t>
+              <a:t>03.09.2026</a:t>
             </a:fld>
             <a:endParaRPr lang="ru-RU"/>
           </a:p>
@@ -2529,7 +2529,7 @@
           <a:p>
             <a:fld id="{51224D22-9B29-44A6-8E82-95FC492DEDC1}" type="datetime1">
               <a:rPr lang="ru-RU" smtClean="0"/>
-              <a:t>02.09.2026</a:t>
+              <a:t>03.09.2026</a:t>
             </a:fld>
             <a:endParaRPr lang="ru-RU"/>
           </a:p>
@@ -2807,7 +2807,7 @@
           <a:p>
             <a:fld id="{91D1034F-4441-48A1-BDC0-25EA1022324A}" type="datetime1">
               <a:rPr lang="ru-RU" smtClean="0"/>
-              <a:t>02.09.2026</a:t>
+              <a:t>03.09.2026</a:t>
             </a:fld>
             <a:endParaRPr lang="ru-RU"/>
           </a:p>
@@ -3062,7 +3062,7 @@
           <a:p>
             <a:fld id="{B0FFDE79-B627-473B-AE17-4C65BD2495F7}" type="datetime1">
               <a:rPr lang="ru-RU" smtClean="0"/>
-              <a:t>02.09.2026</a:t>
+              <a:t>03.09.2026</a:t>
             </a:fld>
             <a:endParaRPr lang="ru-RU"/>
           </a:p>
@@ -3276,7 +3276,7 @@
           <a:p>
             <a:fld id="{11CA537A-1B8C-47BA-9BA6-7CE3FAFDA8BE}" type="datetime1">
               <a:rPr lang="ru-RU" smtClean="0"/>
-              <a:t>02.09.2026</a:t>
+              <a:t>03.09.2026</a:t>
             </a:fld>
             <a:endParaRPr lang="ru-RU"/>
           </a:p>
@@ -11073,8 +11073,8 @@
           </a:p>
         </p:txBody>
       </p:sp>
-      <mc:AlternateContent xmlns:mc="http://schemas.openxmlformats.org/markup-compatibility/2006">
-        <mc:Choice xmlns:a14="http://schemas.microsoft.com/office/drawing/2010/main" Requires="a14">
+      <mc:AlternateContent xmlns:mc="http://schemas.openxmlformats.org/markup-compatibility/2006" xmlns:a14="http://schemas.microsoft.com/office/drawing/2010/main">
+        <mc:Choice Requires="a14">
           <p:sp>
             <p:nvSpPr>
               <p:cNvPr id="3" name="Объект 2"/>
@@ -11485,7 +11485,7 @@
             </p:txBody>
           </p:sp>
         </mc:Choice>
-        <mc:Fallback>
+        <mc:Fallback xmlns="">
           <p:sp>
             <p:nvSpPr>
               <p:cNvPr id="3" name="Объект 2"/>
@@ -18332,8 +18332,8 @@
           </a:p>
         </p:txBody>
       </p:sp>
-      <mc:AlternateContent xmlns:mc="http://schemas.openxmlformats.org/markup-compatibility/2006">
-        <mc:Choice xmlns:a14="http://schemas.microsoft.com/office/drawing/2010/main" Requires="a14">
+      <mc:AlternateContent xmlns:mc="http://schemas.openxmlformats.org/markup-compatibility/2006" xmlns:a14="http://schemas.microsoft.com/office/drawing/2010/main">
+        <mc:Choice Requires="a14">
           <p:sp>
             <p:nvSpPr>
               <p:cNvPr id="3" name="Объект 2"/>
@@ -19376,7 +19376,7 @@
             </p:txBody>
           </p:sp>
         </mc:Choice>
-        <mc:Fallback>
+        <mc:Fallback xmlns="">
           <p:sp>
             <p:nvSpPr>
               <p:cNvPr id="3" name="Объект 2"/>
@@ -31155,8 +31155,8 @@
           </a:p>
         </p:txBody>
       </p:sp>
-      <mc:AlternateContent xmlns:mc="http://schemas.openxmlformats.org/markup-compatibility/2006">
-        <mc:Choice xmlns:a14="http://schemas.microsoft.com/office/drawing/2010/main" Requires="a14">
+      <mc:AlternateContent xmlns:mc="http://schemas.openxmlformats.org/markup-compatibility/2006" xmlns:a14="http://schemas.microsoft.com/office/drawing/2010/main">
+        <mc:Choice Requires="a14">
           <p:sp>
             <p:nvSpPr>
               <p:cNvPr id="3" name="Объект 2"/>
@@ -31505,7 +31505,7 @@
             </p:txBody>
           </p:sp>
         </mc:Choice>
-        <mc:Fallback>
+        <mc:Fallback xmlns="">
           <p:sp>
             <p:nvSpPr>
               <p:cNvPr id="3" name="Объект 2"/>
@@ -37935,8 +37935,8 @@
           </a:p>
         </p:txBody>
       </p:sp>
-      <mc:AlternateContent xmlns:mc="http://schemas.openxmlformats.org/markup-compatibility/2006">
-        <mc:Choice xmlns:a14="http://schemas.microsoft.com/office/drawing/2010/main" Requires="a14">
+      <mc:AlternateContent xmlns:mc="http://schemas.openxmlformats.org/markup-compatibility/2006" xmlns:a14="http://schemas.microsoft.com/office/drawing/2010/main">
+        <mc:Choice Requires="a14">
           <p:sp>
             <p:nvSpPr>
               <p:cNvPr id="3" name="Объект 2"/>
@@ -38998,7 +38998,7 @@
             </p:txBody>
           </p:sp>
         </mc:Choice>
-        <mc:Fallback>
+        <mc:Fallback xmlns="">
           <p:sp>
             <p:nvSpPr>
               <p:cNvPr id="3" name="Объект 2"/>
@@ -40193,13 +40193,7 @@
                         <a:rPr lang="en-US" b="0" i="1" smtClean="0">
                           <a:latin typeface="Cambria Math" panose="02040503050406030204" pitchFamily="18" charset="0"/>
                         </a:rPr>
-                        <m:t>(бросок монетки, одна из стор</m:t>
-                      </m:r>
-                      <m:r>
-                        <a:rPr lang="ru-RU" b="0" i="1" smtClean="0">
-                          <a:latin typeface="Cambria Math" panose="02040503050406030204" pitchFamily="18" charset="0"/>
-                        </a:rPr>
-                        <m:t>он которой тяжелее)</m:t>
+                        <m:t>(бросок монетки, одна из сторон которой тяжелее)</m:t>
                       </m:r>
                     </m:oMath>
                   </m:oMathPara>
@@ -40398,7 +40392,15 @@
           <a:p>
             <a:r>
               <a:rPr lang="ru-RU" dirty="0"/>
-              <a:t>Эквивалентные определения идеального шифра</a:t>
+              <a:t>Эквивалентные определения </a:t>
+            </a:r>
+            <a:r>
+              <a:rPr lang="ru-RU"/>
+              <a:t>абсолютно стойкого </a:t>
+            </a:r>
+            <a:r>
+              <a:rPr lang="ru-RU" dirty="0"/>
+              <a:t>шифра</a:t>
             </a:r>
           </a:p>
         </p:txBody>

</xml_diff>